<commit_message>
Fix a deck that PowerPoint refused to open
The previous deck could not be opened in PowerPoint at all, despite passing
the XSD validator and opening fine in python-pptx. Confirmed by exporting via
PowerPoint COM: a trivial control deck opened, ours did not.

Bisected to the architecture slide. Its arrow helper wrote lines as
x1,y1 -> x2,y2 without normalising, so an upward arrow produced a negative
height. OOXML extents must be non-negative; PowerPoint rejects the package
outright while every other tool accepts it. Arrows are now normalised with
flipH/flipV.

Also pins the three-column lists to the top. Text is vertically centred by
default, so columns with different item counts started at visibly different
heights.

Verified the proper way this time: exported all ten slides through PowerPoint
itself and looked at them, rather than trusting a validator that had already
passed a broken file.

Co-Authored-By: Claude Opus 5 <noreply@anthropic.com>
</commit_message>
<xml_diff>
--- a/docs/SDR-Autopilot-Deck.pptx
+++ b/docs/SDR-Autopilot-Deck.pptx
@@ -4557,7 +4557,7 @@
           <a:ln/>
         </p:spPr>
         <p:txBody>
-          <a:bodyPr wrap="square" lIns="0" tIns="0" rIns="0" bIns="0" rtlCol="0" anchor="ctr"/>
+          <a:bodyPr wrap="square" lIns="0" tIns="0" rIns="0" bIns="0" rtlCol="0" anchor="t"/>
           <a:lstStyle/>
           <a:p>
             <a:pPr marL="342900" indent="-342900">
@@ -4829,7 +4829,7 @@
           <a:ln/>
         </p:spPr>
         <p:txBody>
-          <a:bodyPr wrap="square" lIns="0" tIns="0" rIns="0" bIns="0" rtlCol="0" anchor="ctr"/>
+          <a:bodyPr wrap="square" lIns="0" tIns="0" rIns="0" bIns="0" rtlCol="0" anchor="t"/>
           <a:lstStyle/>
           <a:p>
             <a:pPr marL="342900" indent="-342900">
@@ -5961,9 +5961,9 @@
           <p:nvPr/>
         </p:nvSpPr>
         <p:spPr>
-          <a:xfrm>
-            <a:off x="3840480" y="4233672"/>
-            <a:ext cx="685800" cy="-530352"/>
+          <a:xfrm flipV="1">
+            <a:off x="3840480" y="3703320"/>
+            <a:ext cx="685800" cy="530352"/>
           </a:xfrm>
           <a:prstGeom prst="line">
             <a:avLst/>
@@ -5985,9 +5985,9 @@
           <p:nvPr/>
         </p:nvSpPr>
         <p:spPr>
-          <a:xfrm>
-            <a:off x="7635240" y="3017520"/>
-            <a:ext cx="685800" cy="-1005840"/>
+          <a:xfrm flipV="1">
+            <a:off x="7635240" y="2011680"/>
+            <a:ext cx="685800" cy="1005840"/>
           </a:xfrm>
           <a:prstGeom prst="line">
             <a:avLst/>
@@ -8556,7 +8556,7 @@
           <a:ln/>
         </p:spPr>
         <p:txBody>
-          <a:bodyPr wrap="square" lIns="0" tIns="0" rIns="0" bIns="0" rtlCol="0" anchor="ctr"/>
+          <a:bodyPr wrap="square" lIns="0" tIns="0" rIns="0" bIns="0" rtlCol="0" anchor="t"/>
           <a:lstStyle/>
           <a:p>
             <a:pPr marL="342900" indent="-342900">
@@ -10450,7 +10450,7 @@
           <a:ln/>
         </p:spPr>
         <p:txBody>
-          <a:bodyPr wrap="square" lIns="0" tIns="0" rIns="0" bIns="0" rtlCol="0" anchor="ctr"/>
+          <a:bodyPr wrap="square" lIns="0" tIns="0" rIns="0" bIns="0" rtlCol="0" anchor="t"/>
           <a:lstStyle/>
           <a:p>
             <a:pPr marL="342900" indent="-342900">
@@ -10680,7 +10680,7 @@
           <a:ln/>
         </p:spPr>
         <p:txBody>
-          <a:bodyPr wrap="square" lIns="0" tIns="0" rIns="0" bIns="0" rtlCol="0" anchor="ctr"/>
+          <a:bodyPr wrap="square" lIns="0" tIns="0" rIns="0" bIns="0" rtlCol="0" anchor="t"/>
           <a:lstStyle/>
           <a:p>
             <a:pPr marL="342900" indent="-342900">
@@ -10838,7 +10838,7 @@
           <a:ln/>
         </p:spPr>
         <p:txBody>
-          <a:bodyPr wrap="square" lIns="0" tIns="0" rIns="0" bIns="0" rtlCol="0" anchor="ctr"/>
+          <a:bodyPr wrap="square" lIns="0" tIns="0" rIns="0" bIns="0" rtlCol="0" anchor="t"/>
           <a:lstStyle/>
           <a:p>
             <a:pPr marL="342900" indent="-342900">

</xml_diff>